<commit_message>
Add YOLO and SAM model benchmark tab
Co-Authored-By: Claude Opus 5.5 <noreply@anthropic.com>
</commit_message>
<xml_diff>
--- a/docs/M31_slides_team.pptx
+++ b/docs/M31_slides_team.pptx
@@ -11,6 +11,7 @@
     <p:sldId id="259" r:id="rId11"/>
     <p:sldId id="260" r:id="rId12"/>
     <p:sldId id="261" r:id="rId13"/>
+    <p:sldId id="264" r:id="rId16"/>
     <p:sldId id="262" r:id="rId14"/>
     <p:sldId id="263" r:id="rId15"/>
   </p:sldIdLst>
@@ -1282,6 +1283,82 @@
           <a:p>
             <a:r>
               <a:t>Kết: M31 hiện là công cụ minh bạch và một khung đánh giá trung thực; muốn có mô hình hữu ích cần thêm dữ liệu sửa và đánh giá trên ảnh mới.</a:t>
+            </a:r>
+          </a:p>
+        </p:txBody>
+      </p:sp>
+      <p:sp>
+        <p:nvSpPr>
+          <p:cNvPr id="4" name="Slide Number Placeholder 3"/>
+          <p:cNvSpPr>
+            <a:spLocks noGrp="1"/>
+          </p:cNvSpPr>
+          <p:nvPr>
+            <p:ph type="sldNum" idx="5" sz="quarter"/>
+          </p:nvPr>
+        </p:nvSpPr>
+        <p:spPr/>
+      </p:sp>
+    </p:spTree>
+  </p:cSld>
+  <p:clrMapOvr>
+    <a:masterClrMapping/>
+  </p:clrMapOvr>
+</p:notes>
+</file>
+
+<file path=ppt/notesSlides/notesSlide9.xml><?xml version="1.0" encoding="utf-8"?>
+<p:notes xmlns:a="http://schemas.openxmlformats.org/drawingml/2006/main" xmlns:p="http://schemas.openxmlformats.org/presentationml/2006/main" xmlns:r="http://schemas.openxmlformats.org/officeDocument/2006/relationships">
+  <p:cSld>
+    <p:spTree>
+      <p:nvGrpSpPr>
+        <p:cNvPr id="1" name=""/>
+        <p:cNvGrpSpPr/>
+        <p:nvPr/>
+      </p:nvGrpSpPr>
+      <p:grpSpPr>
+        <a:xfrm>
+          <a:off x="0" y="0"/>
+          <a:ext cx="0" cy="0"/>
+          <a:chOff x="0" y="0"/>
+          <a:chExt cx="0" cy="0"/>
+        </a:xfrm>
+      </p:grpSpPr>
+      <p:sp>
+        <p:nvSpPr>
+          <p:cNvPr id="2" name="Slide Image Placeholder 1"/>
+          <p:cNvSpPr>
+            <a:spLocks noGrp="1"/>
+          </p:cNvSpPr>
+          <p:nvPr>
+            <p:ph type="sldImg" idx="2"/>
+          </p:nvPr>
+        </p:nvSpPr>
+        <p:spPr/>
+      </p:sp>
+      <p:sp>
+        <p:nvSpPr>
+          <p:cNvPr id="3" name="Notes Placeholder 2"/>
+          <p:cNvSpPr>
+            <a:spLocks noGrp="1"/>
+          </p:cNvSpPr>
+          <p:nvPr>
+            <p:ph type="body" idx="3" sz="quarter"/>
+          </p:nvPr>
+        </p:nvSpPr>
+        <p:spPr/>
+        <p:txBody>
+          <a:bodyPr/>
+          <a:lstStyle/>
+          <a:p>
+            <a:r>
+              <a:t>So sánh model (pilot 100 ảnh BDD100K, lớp car, RTX 2060): đã thử 22 phiên bản YOLO và 11 phiên bản SAM trên cùng tập pilot, với cấu hình thống nhất trong từng nhóm model. Với cùng box prompt YOLOv8n, SAM2-T/S chạy nhanh hơn SAM-B khoảng 2,2–2,5 lần; IoU trên 92 ảnh có prompt cao hơn nhẹ (+0,012…+0,016), nhưng kết quả chỉ mang tính khám phá. Chất lượng detection chưa xếp hạng được một cách đáng tin cậy vì chỉ 14 ảnh (126 box) có nhãn. Nhóm giữ YOLOv8n + SAM-B làm mặc định; các ứng viên cần được kiểm chứng trên tập ảnh mới có nhãn.</a:t>
+            </a:r>
+          </a:p>
+          <a:p/>
+          <a:p>
+            <a:r>
+              <a:t>Chi tiết phương pháp: YOLO dùng imgsz 640, conf 0,25, NMS theo lớp IoU 0,7, lọc lớp car; precision/recall chấm trên 14 ảnh có nhãn box (126 box), 86 ảnh còn lại không chấm. SAM được đánh giá với cùng 555 box prompt từ YOLOv8n; IoU so với nhãn segmentation BDD100K (car), chỉ số chính trên 92 ảnh có prompt. Khoảng tin cậy bootstrap theo ảnh. Có nhiều phép so sánh trên mẫu nhỏ, chưa hiệu chỉnh, nên không có model nào được coi là tốt nhất; kết quả không đại diện cho toàn bộ BDD100K. Báo cáo: docs/11, docs/12, docs/13.</a:t>
             </a:r>
           </a:p>
         </p:txBody>
@@ -8502,21 +8579,60 @@
                 </a:solidFill>
                 <a:latin typeface="Cambria"/>
               </a:rPr>
-              <a:t>Giới hạn cần nói rõ</a:t>
-            </a:r>
-          </a:p>
-        </p:txBody>
-      </p:sp>
-      <p:sp>
-        <p:nvSpPr>
-          <p:cNvPr id="3" name="Rounded Rectangle 2"/>
+              <a:t>So sánh model trên pilot: giữ mặc định</a:t>
+            </a:r>
+          </a:p>
+        </p:txBody>
+      </p:sp>
+      <p:sp>
+        <p:nvSpPr>
+          <p:cNvPr id="3" name="TextBox 2"/>
+          <p:cNvSpPr txBox="1"/>
+          <p:nvPr/>
+        </p:nvSpPr>
+        <p:spPr>
+          <a:xfrm>
+            <a:off x="548640" y="1188720"/>
+            <a:ext cx="11064240" cy="457200"/>
+          </a:xfrm>
+          <a:prstGeom prst="rect">
+            <a:avLst/>
+          </a:prstGeom>
+          <a:noFill/>
+        </p:spPr>
+        <p:txBody>
+          <a:bodyPr wrap="square" anchor="t" lIns="0" rIns="0" tIns="0" bIns="0">
+            <a:spAutoFit/>
+          </a:bodyPr>
+          <a:lstStyle/>
+          <a:p>
+            <a:pPr algn="l">
+              <a:spcAft>
+                <a:spcPts val="600"/>
+              </a:spcAft>
+            </a:pPr>
+            <a:r>
+              <a:rPr sz="1500" b="0" i="0">
+                <a:solidFill>
+                  <a:srgbClr val="4A5560"/>
+                </a:solidFill>
+                <a:latin typeface="Calibri"/>
+              </a:rPr>
+              <a:t>Pilot 100 ảnh BDD100K · lớp car · RTX 2060 · 22 phiên bản YOLO, 11 phiên bản SAM, cấu hình thống nhất trong từng nhóm</a:t>
+            </a:r>
+          </a:p>
+        </p:txBody>
+      </p:sp>
+      <p:sp>
+        <p:nvSpPr>
+          <p:cNvPr id="4" name="ModelCard1"/>
           <p:cNvSpPr/>
           <p:nvPr/>
         </p:nvSpPr>
         <p:spPr>
           <a:xfrm>
-            <a:off x="548640" y="1508760"/>
-            <a:ext cx="5440680" cy="1280160"/>
+            <a:off x="548640" y="1828800"/>
+            <a:ext cx="3474720" cy="2331720"/>
           </a:xfrm>
           <a:prstGeom prst="roundRect">
             <a:avLst>
@@ -8555,67 +8671,14 @@
       </p:sp>
       <p:sp>
         <p:nvSpPr>
-          <p:cNvPr id="4" name="Oval 3"/>
-          <p:cNvSpPr/>
-          <p:nvPr/>
-        </p:nvSpPr>
-        <p:spPr>
-          <a:xfrm>
-            <a:off x="822960" y="1892808"/>
-            <a:ext cx="502920" cy="502920"/>
-          </a:xfrm>
-          <a:prstGeom prst="ellipse">
-            <a:avLst/>
-          </a:prstGeom>
-          <a:solidFill>
-            <a:srgbClr val="F2B705"/>
-          </a:solidFill>
-          <a:ln>
-            <a:noFill/>
-          </a:ln>
-          <a:effectLst/>
-        </p:spPr>
-        <p:style>
-          <a:lnRef idx="1">
-            <a:schemeClr val="accent1"/>
-          </a:lnRef>
-          <a:fillRef idx="3">
-            <a:schemeClr val="accent1"/>
-          </a:fillRef>
-          <a:effectRef idx="2">
-            <a:schemeClr val="accent1"/>
-          </a:effectRef>
-          <a:fontRef idx="minor">
-            <a:schemeClr val="lt1"/>
-          </a:fontRef>
-        </p:style>
-        <p:txBody>
-          <a:bodyPr rtlCol="0" anchor="ctr" lIns="0" rIns="0" tIns="0" bIns="0"/>
-          <a:lstStyle/>
-          <a:p>
-            <a:pPr algn="ctr"/>
-            <a:r>
-              <a:rPr sz="1600" b="1">
-                <a:solidFill>
-                  <a:srgbClr val="22272E"/>
-                </a:solidFill>
-                <a:latin typeface="Calibri"/>
-              </a:rPr>
-              <a:t>1</a:t>
-            </a:r>
-          </a:p>
-        </p:txBody>
-      </p:sp>
-      <p:sp>
-        <p:nvSpPr>
           <p:cNvPr id="5" name="TextBox 4"/>
           <p:cNvSpPr txBox="1"/>
           <p:nvPr/>
         </p:nvSpPr>
         <p:spPr>
           <a:xfrm>
-            <a:off x="1554480" y="1691640"/>
-            <a:ext cx="4206240" cy="411480"/>
+            <a:off x="822960" y="2103120"/>
+            <a:ext cx="3017520" cy="731520"/>
           </a:xfrm>
           <a:prstGeom prst="rect">
             <a:avLst/>
@@ -8634,13 +8697,13 @@
               </a:spcAft>
             </a:pPr>
             <a:r>
-              <a:rPr sz="1800" b="1" i="0">
+              <a:rPr sz="2800" b="1" i="0">
                 <a:solidFill>
                   <a:srgbClr val="22272E"/>
                 </a:solidFill>
-                <a:latin typeface="Calibri"/>
+                <a:latin typeface="Cambria"/>
               </a:rPr>
-              <a:t>Mẫu nhỏ</a:t>
+              <a:t>2,2–2,5×</a:t>
             </a:r>
           </a:p>
         </p:txBody>
@@ -8653,8 +8716,8 @@
         </p:nvSpPr>
         <p:spPr>
           <a:xfrm>
-            <a:off x="1554480" y="2103120"/>
-            <a:ext cx="4206240" cy="640080"/>
+            <a:off x="822960" y="2971800"/>
+            <a:ext cx="3017520" cy="457200"/>
           </a:xfrm>
           <a:prstGeom prst="rect">
             <a:avLst/>
@@ -8673,27 +8736,66 @@
               </a:spcAft>
             </a:pPr>
             <a:r>
-              <a:rPr sz="1400" b="0" i="0">
-                <a:solidFill>
-                  <a:srgbClr val="4A5560"/>
+              <a:rPr sz="1600" b="1" i="0">
+                <a:solidFill>
+                  <a:srgbClr val="22272E"/>
                 </a:solidFill>
                 <a:latin typeface="Calibri"/>
               </a:rPr>
-              <a:t>100 ảnh, 1 lớp, 13 ca sửa mỗi task — không đại diện BDD100K</a:t>
-            </a:r>
-          </a:p>
-        </p:txBody>
-      </p:sp>
-      <p:sp>
-        <p:nvSpPr>
-          <p:cNvPr id="7" name="Rounded Rectangle 6"/>
+              <a:t>SAM2-T/S nhanh hơn SAM-B</a:t>
+            </a:r>
+          </a:p>
+        </p:txBody>
+      </p:sp>
+      <p:sp>
+        <p:nvSpPr>
+          <p:cNvPr id="7" name="TextBox 6"/>
+          <p:cNvSpPr txBox="1"/>
+          <p:nvPr/>
+        </p:nvSpPr>
+        <p:spPr>
+          <a:xfrm>
+            <a:off x="822960" y="3429000"/>
+            <a:ext cx="3017520" cy="640080"/>
+          </a:xfrm>
+          <a:prstGeom prst="rect">
+            <a:avLst/>
+          </a:prstGeom>
+          <a:noFill/>
+        </p:spPr>
+        <p:txBody>
+          <a:bodyPr wrap="square" anchor="t" lIns="0" rIns="0" tIns="0" bIns="0">
+            <a:spAutoFit/>
+          </a:bodyPr>
+          <a:lstStyle/>
+          <a:p>
+            <a:pPr algn="l">
+              <a:spcAft>
+                <a:spcPts val="600"/>
+              </a:spcAft>
+            </a:pPr>
+            <a:r>
+              <a:rPr sz="1300" b="0" i="0">
+                <a:solidFill>
+                  <a:srgbClr val="4A5560"/>
+                </a:solidFill>
+                <a:latin typeface="Calibri"/>
+              </a:rPr>
+              <a:t>Cùng box prompt YOLOv8n cho mọi SAM</a:t>
+            </a:r>
+          </a:p>
+        </p:txBody>
+      </p:sp>
+      <p:sp>
+        <p:nvSpPr>
+          <p:cNvPr id="8" name="ModelCard2"/>
           <p:cNvSpPr/>
           <p:nvPr/>
         </p:nvSpPr>
         <p:spPr>
           <a:xfrm>
-            <a:off x="6172200" y="1508760"/>
-            <a:ext cx="5440680" cy="1280160"/>
+            <a:off x="4297679" y="1828800"/>
+            <a:ext cx="3474720" cy="2331720"/>
           </a:xfrm>
           <a:prstGeom prst="roundRect">
             <a:avLst>
@@ -8732,67 +8834,14 @@
       </p:sp>
       <p:sp>
         <p:nvSpPr>
-          <p:cNvPr id="8" name="Oval 7"/>
-          <p:cNvSpPr/>
-          <p:nvPr/>
-        </p:nvSpPr>
-        <p:spPr>
-          <a:xfrm>
-            <a:off x="6446520" y="1892808"/>
-            <a:ext cx="502920" cy="502920"/>
-          </a:xfrm>
-          <a:prstGeom prst="ellipse">
-            <a:avLst/>
-          </a:prstGeom>
-          <a:solidFill>
-            <a:srgbClr val="F2B705"/>
-          </a:solidFill>
-          <a:ln>
-            <a:noFill/>
-          </a:ln>
-          <a:effectLst/>
-        </p:spPr>
-        <p:style>
-          <a:lnRef idx="1">
-            <a:schemeClr val="accent1"/>
-          </a:lnRef>
-          <a:fillRef idx="3">
-            <a:schemeClr val="accent1"/>
-          </a:fillRef>
-          <a:effectRef idx="2">
-            <a:schemeClr val="accent1"/>
-          </a:effectRef>
-          <a:fontRef idx="minor">
-            <a:schemeClr val="lt1"/>
-          </a:fontRef>
-        </p:style>
-        <p:txBody>
-          <a:bodyPr rtlCol="0" anchor="ctr" lIns="0" rIns="0" tIns="0" bIns="0"/>
-          <a:lstStyle/>
-          <a:p>
-            <a:pPr algn="ctr"/>
-            <a:r>
-              <a:rPr sz="1600" b="1">
-                <a:solidFill>
-                  <a:srgbClr val="22272E"/>
-                </a:solidFill>
-                <a:latin typeface="Calibri"/>
-              </a:rPr>
-              <a:t>2</a:t>
-            </a:r>
-          </a:p>
-        </p:txBody>
-      </p:sp>
-      <p:sp>
-        <p:nvSpPr>
           <p:cNvPr id="9" name="TextBox 8"/>
           <p:cNvSpPr txBox="1"/>
           <p:nvPr/>
         </p:nvSpPr>
         <p:spPr>
           <a:xfrm>
-            <a:off x="7178040" y="1691640"/>
-            <a:ext cx="4206240" cy="411480"/>
+            <a:off x="4571999" y="2103120"/>
+            <a:ext cx="3017520" cy="731520"/>
           </a:xfrm>
           <a:prstGeom prst="rect">
             <a:avLst/>
@@ -8811,13 +8860,13 @@
               </a:spcAft>
             </a:pPr>
             <a:r>
-              <a:rPr sz="1800" b="1" i="0">
+              <a:rPr sz="2800" b="1" i="0">
                 <a:solidFill>
                   <a:srgbClr val="22272E"/>
                 </a:solidFill>
-                <a:latin typeface="Calibri"/>
+                <a:latin typeface="Cambria"/>
               </a:rPr>
-              <a:t>Baseline giả định</a:t>
+              <a:t>+0,012…+0,016</a:t>
             </a:r>
           </a:p>
         </p:txBody>
@@ -8830,8 +8879,8 @@
         </p:nvSpPr>
         <p:spPr>
           <a:xfrm>
-            <a:off x="7178040" y="2103120"/>
-            <a:ext cx="4206240" cy="640080"/>
+            <a:off x="4571999" y="2971800"/>
+            <a:ext cx="3017520" cy="457200"/>
           </a:xfrm>
           <a:prstGeom prst="rect">
             <a:avLst/>
@@ -8850,27 +8899,66 @@
               </a:spcAft>
             </a:pPr>
             <a:r>
-              <a:rPr sz="1400" b="0" i="0">
-                <a:solidFill>
-                  <a:srgbClr val="4A5560"/>
+              <a:rPr sz="1600" b="1" i="0">
+                <a:solidFill>
+                  <a:srgbClr val="22272E"/>
                 </a:solidFill>
                 <a:latin typeface="Calibri"/>
               </a:rPr>
-              <a:t>Hằng số thời gian sửa đặt tay; điểm chất lượng chưa kiểm chứng</a:t>
-            </a:r>
-          </a:p>
-        </p:txBody>
-      </p:sp>
-      <p:sp>
-        <p:nvSpPr>
-          <p:cNvPr id="11" name="Rounded Rectangle 10"/>
+              <a:t>IoU cao hơn nhẹ so với SAM-B</a:t>
+            </a:r>
+          </a:p>
+        </p:txBody>
+      </p:sp>
+      <p:sp>
+        <p:nvSpPr>
+          <p:cNvPr id="11" name="TextBox 10"/>
+          <p:cNvSpPr txBox="1"/>
+          <p:nvPr/>
+        </p:nvSpPr>
+        <p:spPr>
+          <a:xfrm>
+            <a:off x="4571999" y="3429000"/>
+            <a:ext cx="3017520" cy="640080"/>
+          </a:xfrm>
+          <a:prstGeom prst="rect">
+            <a:avLst/>
+          </a:prstGeom>
+          <a:noFill/>
+        </p:spPr>
+        <p:txBody>
+          <a:bodyPr wrap="square" anchor="t" lIns="0" rIns="0" tIns="0" bIns="0">
+            <a:spAutoFit/>
+          </a:bodyPr>
+          <a:lstStyle/>
+          <a:p>
+            <a:pPr algn="l">
+              <a:spcAft>
+                <a:spcPts val="600"/>
+              </a:spcAft>
+            </a:pPr>
+            <a:r>
+              <a:rPr sz="1300" b="0" i="0">
+                <a:solidFill>
+                  <a:srgbClr val="4A5560"/>
+                </a:solidFill>
+                <a:latin typeface="Calibri"/>
+              </a:rPr>
+              <a:t>Trên 92 ảnh có prompt · chỉ mang tính khám phá</a:t>
+            </a:r>
+          </a:p>
+        </p:txBody>
+      </p:sp>
+      <p:sp>
+        <p:nvSpPr>
+          <p:cNvPr id="12" name="ModelCard3"/>
           <p:cNvSpPr/>
           <p:nvPr/>
         </p:nvSpPr>
         <p:spPr>
           <a:xfrm>
-            <a:off x="548640" y="2971800"/>
-            <a:ext cx="5440680" cy="1280160"/>
+            <a:off x="8046719" y="1828800"/>
+            <a:ext cx="3474720" cy="2331720"/>
           </a:xfrm>
           <a:prstGeom prst="roundRect">
             <a:avLst>
@@ -8909,20 +8997,139 @@
       </p:sp>
       <p:sp>
         <p:nvSpPr>
-          <p:cNvPr id="12" name="Oval 11"/>
+          <p:cNvPr id="13" name="TextBox 12"/>
+          <p:cNvSpPr txBox="1"/>
+          <p:nvPr/>
+        </p:nvSpPr>
+        <p:spPr>
+          <a:xfrm>
+            <a:off x="8321039" y="2103120"/>
+            <a:ext cx="3017520" cy="731520"/>
+          </a:xfrm>
+          <a:prstGeom prst="rect">
+            <a:avLst/>
+          </a:prstGeom>
+          <a:noFill/>
+        </p:spPr>
+        <p:txBody>
+          <a:bodyPr wrap="square" anchor="t" lIns="0" rIns="0" tIns="0" bIns="0">
+            <a:spAutoFit/>
+          </a:bodyPr>
+          <a:lstStyle/>
+          <a:p>
+            <a:pPr algn="l">
+              <a:spcAft>
+                <a:spcPts val="600"/>
+              </a:spcAft>
+            </a:pPr>
+            <a:r>
+              <a:rPr sz="2800" b="1" i="0">
+                <a:solidFill>
+                  <a:srgbClr val="22272E"/>
+                </a:solidFill>
+                <a:latin typeface="Cambria"/>
+              </a:rPr>
+              <a:t>14 ảnh</a:t>
+            </a:r>
+          </a:p>
+        </p:txBody>
+      </p:sp>
+      <p:sp>
+        <p:nvSpPr>
+          <p:cNvPr id="14" name="TextBox 13"/>
+          <p:cNvSpPr txBox="1"/>
+          <p:nvPr/>
+        </p:nvSpPr>
+        <p:spPr>
+          <a:xfrm>
+            <a:off x="8321039" y="2971800"/>
+            <a:ext cx="3017520" cy="457200"/>
+          </a:xfrm>
+          <a:prstGeom prst="rect">
+            <a:avLst/>
+          </a:prstGeom>
+          <a:noFill/>
+        </p:spPr>
+        <p:txBody>
+          <a:bodyPr wrap="square" anchor="t" lIns="0" rIns="0" tIns="0" bIns="0">
+            <a:spAutoFit/>
+          </a:bodyPr>
+          <a:lstStyle/>
+          <a:p>
+            <a:pPr algn="l">
+              <a:spcAft>
+                <a:spcPts val="600"/>
+              </a:spcAft>
+            </a:pPr>
+            <a:r>
+              <a:rPr sz="1600" b="1" i="0">
+                <a:solidFill>
+                  <a:srgbClr val="22272E"/>
+                </a:solidFill>
+                <a:latin typeface="Calibri"/>
+              </a:rPr>
+              <a:t>Detection chưa xếp hạng được</a:t>
+            </a:r>
+          </a:p>
+        </p:txBody>
+      </p:sp>
+      <p:sp>
+        <p:nvSpPr>
+          <p:cNvPr id="15" name="TextBox 14"/>
+          <p:cNvSpPr txBox="1"/>
+          <p:nvPr/>
+        </p:nvSpPr>
+        <p:spPr>
+          <a:xfrm>
+            <a:off x="8321039" y="3429000"/>
+            <a:ext cx="3017520" cy="640080"/>
+          </a:xfrm>
+          <a:prstGeom prst="rect">
+            <a:avLst/>
+          </a:prstGeom>
+          <a:noFill/>
+        </p:spPr>
+        <p:txBody>
+          <a:bodyPr wrap="square" anchor="t" lIns="0" rIns="0" tIns="0" bIns="0">
+            <a:spAutoFit/>
+          </a:bodyPr>
+          <a:lstStyle/>
+          <a:p>
+            <a:pPr algn="l">
+              <a:spcAft>
+                <a:spcPts val="600"/>
+              </a:spcAft>
+            </a:pPr>
+            <a:r>
+              <a:rPr sz="1300" b="0" i="0">
+                <a:solidFill>
+                  <a:srgbClr val="4A5560"/>
+                </a:solidFill>
+                <a:latin typeface="Calibri"/>
+              </a:rPr>
+              <a:t>Chỉ 14 ảnh (126 box) có nhãn</a:t>
+            </a:r>
+          </a:p>
+        </p:txBody>
+      </p:sp>
+      <p:sp>
+        <p:nvSpPr>
+          <p:cNvPr id="16" name="ModelDecision"/>
           <p:cNvSpPr/>
           <p:nvPr/>
         </p:nvSpPr>
         <p:spPr>
           <a:xfrm>
-            <a:off x="822960" y="3355848"/>
-            <a:ext cx="502920" cy="502920"/>
-          </a:xfrm>
-          <a:prstGeom prst="ellipse">
-            <a:avLst/>
+            <a:off x="548640" y="4526280"/>
+            <a:ext cx="11064240" cy="1234440"/>
+          </a:xfrm>
+          <a:prstGeom prst="roundRect">
+            <a:avLst>
+              <a:gd name="adj" fmla="val 8000"/>
+            </a:avLst>
           </a:prstGeom>
           <a:solidFill>
-            <a:srgbClr val="F2B705"/>
+            <a:srgbClr val="22272E"/>
           </a:solidFill>
           <a:ln>
             <a:noFill/>
@@ -8944,32 +9151,23 @@
           </a:fontRef>
         </p:style>
         <p:txBody>
-          <a:bodyPr rtlCol="0" anchor="ctr" lIns="0" rIns="0" tIns="0" bIns="0"/>
+          <a:bodyPr rtlCol="0" anchor="ctr"/>
           <a:lstStyle/>
           <a:p>
             <a:pPr algn="ctr"/>
-            <a:r>
-              <a:rPr sz="1600" b="1">
-                <a:solidFill>
-                  <a:srgbClr val="22272E"/>
-                </a:solidFill>
-                <a:latin typeface="Calibri"/>
-              </a:rPr>
-              <a:t>3</a:t>
-            </a:r>
-          </a:p>
-        </p:txBody>
-      </p:sp>
-      <p:sp>
-        <p:nvSpPr>
-          <p:cNvPr id="13" name="TextBox 12"/>
+          </a:p>
+        </p:txBody>
+      </p:sp>
+      <p:sp>
+        <p:nvSpPr>
+          <p:cNvPr id="17" name="TextBox 16"/>
           <p:cNvSpPr txBox="1"/>
           <p:nvPr/>
         </p:nvSpPr>
         <p:spPr>
           <a:xfrm>
-            <a:off x="1554480" y="3154680"/>
-            <a:ext cx="4206240" cy="411480"/>
+            <a:off x="868680" y="4663440"/>
+            <a:ext cx="10424160" cy="960120"/>
           </a:xfrm>
           <a:prstGeom prst="rect">
             <a:avLst/>
@@ -8977,7 +9175,7 @@
           <a:noFill/>
         </p:spPr>
         <p:txBody>
-          <a:bodyPr wrap="square" anchor="t" lIns="0" rIns="0" tIns="0" bIns="0">
+          <a:bodyPr wrap="square" anchor="ctr" lIns="0" rIns="0" tIns="0" bIns="0">
             <a:spAutoFit/>
           </a:bodyPr>
           <a:lstStyle/>
@@ -8988,38 +9186,24 @@
               </a:spcAft>
             </a:pPr>
             <a:r>
-              <a:rPr sz="1800" b="1" i="0">
-                <a:solidFill>
-                  <a:srgbClr val="22272E"/>
+              <a:rPr sz="1700" b="1" i="0">
+                <a:solidFill>
+                  <a:srgbClr val="F2B705"/>
                 </a:solidFill>
                 <a:latin typeface="Calibri"/>
               </a:rPr>
-              <a:t>SAM</a:t>
-            </a:r>
-          </a:p>
-        </p:txBody>
-      </p:sp>
-      <p:sp>
-        <p:nvSpPr>
-          <p:cNvPr id="14" name="TextBox 13"/>
-          <p:cNvSpPr txBox="1"/>
-          <p:nvPr/>
-        </p:nvSpPr>
-        <p:spPr>
-          <a:xfrm>
-            <a:off x="1554480" y="3566160"/>
-            <a:ext cx="4206240" cy="640080"/>
-          </a:xfrm>
-          <a:prstGeom prst="rect">
-            <a:avLst/>
-          </a:prstGeom>
-          <a:noFill/>
-        </p:spPr>
-        <p:txBody>
-          <a:bodyPr wrap="square" anchor="t" lIns="0" rIns="0" tIns="0" bIns="0">
-            <a:spAutoFit/>
-          </a:bodyPr>
-          <a:lstStyle/>
+              <a:t>Giữ YOLOv8n + SAM-B làm mặc định. </a:t>
+            </a:r>
+            <a:r>
+              <a:rPr sz="1700" b="0" i="0">
+                <a:solidFill>
+                  <a:srgbClr val="FFFFFF"/>
+                </a:solidFill>
+                <a:latin typeface="Calibri"/>
+              </a:rPr>
+              <a:t>Các ứng viên cần được kiểm chứng trên tập ảnh mới có nhãn.</a:t>
+            </a:r>
+          </a:p>
           <a:p>
             <a:pPr algn="l">
               <a:spcAft>
@@ -9029,542 +9213,11 @@
             <a:r>
               <a:rPr sz="1400" b="0" i="0">
                 <a:solidFill>
-                  <a:srgbClr val="4A5560"/>
+                  <a:srgbClr val="D5DAE0"/>
                 </a:solidFill>
                 <a:latin typeface="Calibri"/>
               </a:rPr>
-              <a:t>Không có confidence riêng; dùng confidence box YOLO</a:t>
-            </a:r>
-          </a:p>
-        </p:txBody>
-      </p:sp>
-      <p:sp>
-        <p:nvSpPr>
-          <p:cNvPr id="15" name="Rounded Rectangle 14"/>
-          <p:cNvSpPr/>
-          <p:nvPr/>
-        </p:nvSpPr>
-        <p:spPr>
-          <a:xfrm>
-            <a:off x="6172200" y="2971800"/>
-            <a:ext cx="5440680" cy="1280160"/>
-          </a:xfrm>
-          <a:prstGeom prst="roundRect">
-            <a:avLst>
-              <a:gd name="adj" fmla="val 8000"/>
-            </a:avLst>
-          </a:prstGeom>
-          <a:solidFill>
-            <a:srgbClr val="F1F3F5"/>
-          </a:solidFill>
-          <a:ln>
-            <a:noFill/>
-          </a:ln>
-          <a:effectLst/>
-        </p:spPr>
-        <p:style>
-          <a:lnRef idx="1">
-            <a:schemeClr val="accent1"/>
-          </a:lnRef>
-          <a:fillRef idx="3">
-            <a:schemeClr val="accent1"/>
-          </a:fillRef>
-          <a:effectRef idx="2">
-            <a:schemeClr val="accent1"/>
-          </a:effectRef>
-          <a:fontRef idx="minor">
-            <a:schemeClr val="lt1"/>
-          </a:fontRef>
-        </p:style>
-        <p:txBody>
-          <a:bodyPr rtlCol="0" anchor="ctr"/>
-          <a:lstStyle/>
-          <a:p>
-            <a:pPr algn="ctr"/>
-          </a:p>
-        </p:txBody>
-      </p:sp>
-      <p:sp>
-        <p:nvSpPr>
-          <p:cNvPr id="16" name="Oval 15"/>
-          <p:cNvSpPr/>
-          <p:nvPr/>
-        </p:nvSpPr>
-        <p:spPr>
-          <a:xfrm>
-            <a:off x="6446520" y="3355848"/>
-            <a:ext cx="502920" cy="502920"/>
-          </a:xfrm>
-          <a:prstGeom prst="ellipse">
-            <a:avLst/>
-          </a:prstGeom>
-          <a:solidFill>
-            <a:srgbClr val="F2B705"/>
-          </a:solidFill>
-          <a:ln>
-            <a:noFill/>
-          </a:ln>
-          <a:effectLst/>
-        </p:spPr>
-        <p:style>
-          <a:lnRef idx="1">
-            <a:schemeClr val="accent1"/>
-          </a:lnRef>
-          <a:fillRef idx="3">
-            <a:schemeClr val="accent1"/>
-          </a:fillRef>
-          <a:effectRef idx="2">
-            <a:schemeClr val="accent1"/>
-          </a:effectRef>
-          <a:fontRef idx="minor">
-            <a:schemeClr val="lt1"/>
-          </a:fontRef>
-        </p:style>
-        <p:txBody>
-          <a:bodyPr rtlCol="0" anchor="ctr" lIns="0" rIns="0" tIns="0" bIns="0"/>
-          <a:lstStyle/>
-          <a:p>
-            <a:pPr algn="ctr"/>
-            <a:r>
-              <a:rPr sz="1600" b="1">
-                <a:solidFill>
-                  <a:srgbClr val="22272E"/>
-                </a:solidFill>
-                <a:latin typeface="Calibri"/>
-              </a:rPr>
-              <a:t>4</a:t>
-            </a:r>
-          </a:p>
-        </p:txBody>
-      </p:sp>
-      <p:sp>
-        <p:nvSpPr>
-          <p:cNvPr id="17" name="TextBox 16"/>
-          <p:cNvSpPr txBox="1"/>
-          <p:nvPr/>
-        </p:nvSpPr>
-        <p:spPr>
-          <a:xfrm>
-            <a:off x="7178040" y="3154680"/>
-            <a:ext cx="4206240" cy="411480"/>
-          </a:xfrm>
-          <a:prstGeom prst="rect">
-            <a:avLst/>
-          </a:prstGeom>
-          <a:noFill/>
-        </p:spPr>
-        <p:txBody>
-          <a:bodyPr wrap="square" anchor="t" lIns="0" rIns="0" tIns="0" bIns="0">
-            <a:spAutoFit/>
-          </a:bodyPr>
-          <a:lstStyle/>
-          <a:p>
-            <a:pPr algn="l">
-              <a:spcAft>
-                <a:spcPts val="600"/>
-              </a:spcAft>
-            </a:pPr>
-            <a:r>
-              <a:rPr sz="1800" b="1" i="0">
-                <a:solidFill>
-                  <a:srgbClr val="22272E"/>
-                </a:solidFill>
-                <a:latin typeface="Calibri"/>
-              </a:rPr>
-              <a:t>Đo lường</a:t>
-            </a:r>
-          </a:p>
-        </p:txBody>
-      </p:sp>
-      <p:sp>
-        <p:nvSpPr>
-          <p:cNvPr id="18" name="TextBox 17"/>
-          <p:cNvSpPr txBox="1"/>
-          <p:nvPr/>
-        </p:nvSpPr>
-        <p:spPr>
-          <a:xfrm>
-            <a:off x="7178040" y="3566160"/>
-            <a:ext cx="4206240" cy="640080"/>
-          </a:xfrm>
-          <a:prstGeom prst="rect">
-            <a:avLst/>
-          </a:prstGeom>
-          <a:noFill/>
-        </p:spPr>
-        <p:txBody>
-          <a:bodyPr wrap="square" anchor="t" lIns="0" rIns="0" tIns="0" bIns="0">
-            <a:spAutoFit/>
-          </a:bodyPr>
-          <a:lstStyle/>
-          <a:p>
-            <a:pPr algn="l">
-              <a:spcAft>
-                <a:spcPts val="600"/>
-              </a:spcAft>
-            </a:pPr>
-            <a:r>
-              <a:rPr sz="1400" b="0" i="0">
-                <a:solidFill>
-                  <a:srgbClr val="4A5560"/>
-                </a:solidFill>
-                <a:latin typeface="Calibri"/>
-              </a:rPr>
-              <a:t>Thời gian sửa do nhóm ghi; không có đánh giá với ground truth</a:t>
-            </a:r>
-          </a:p>
-        </p:txBody>
-      </p:sp>
-      <p:sp>
-        <p:nvSpPr>
-          <p:cNvPr id="19" name="Rounded Rectangle 18"/>
-          <p:cNvSpPr/>
-          <p:nvPr/>
-        </p:nvSpPr>
-        <p:spPr>
-          <a:xfrm>
-            <a:off x="548640" y="4434840"/>
-            <a:ext cx="5440680" cy="1280160"/>
-          </a:xfrm>
-          <a:prstGeom prst="roundRect">
-            <a:avLst>
-              <a:gd name="adj" fmla="val 8000"/>
-            </a:avLst>
-          </a:prstGeom>
-          <a:solidFill>
-            <a:srgbClr val="F1F3F5"/>
-          </a:solidFill>
-          <a:ln>
-            <a:noFill/>
-          </a:ln>
-          <a:effectLst/>
-        </p:spPr>
-        <p:style>
-          <a:lnRef idx="1">
-            <a:schemeClr val="accent1"/>
-          </a:lnRef>
-          <a:fillRef idx="3">
-            <a:schemeClr val="accent1"/>
-          </a:fillRef>
-          <a:effectRef idx="2">
-            <a:schemeClr val="accent1"/>
-          </a:effectRef>
-          <a:fontRef idx="minor">
-            <a:schemeClr val="lt1"/>
-          </a:fontRef>
-        </p:style>
-        <p:txBody>
-          <a:bodyPr rtlCol="0" anchor="ctr"/>
-          <a:lstStyle/>
-          <a:p>
-            <a:pPr algn="ctr"/>
-          </a:p>
-        </p:txBody>
-      </p:sp>
-      <p:sp>
-        <p:nvSpPr>
-          <p:cNvPr id="20" name="Oval 19"/>
-          <p:cNvSpPr/>
-          <p:nvPr/>
-        </p:nvSpPr>
-        <p:spPr>
-          <a:xfrm>
-            <a:off x="822960" y="4818888"/>
-            <a:ext cx="502920" cy="502920"/>
-          </a:xfrm>
-          <a:prstGeom prst="ellipse">
-            <a:avLst/>
-          </a:prstGeom>
-          <a:solidFill>
-            <a:srgbClr val="F2B705"/>
-          </a:solidFill>
-          <a:ln>
-            <a:noFill/>
-          </a:ln>
-          <a:effectLst/>
-        </p:spPr>
-        <p:style>
-          <a:lnRef idx="1">
-            <a:schemeClr val="accent1"/>
-          </a:lnRef>
-          <a:fillRef idx="3">
-            <a:schemeClr val="accent1"/>
-          </a:fillRef>
-          <a:effectRef idx="2">
-            <a:schemeClr val="accent1"/>
-          </a:effectRef>
-          <a:fontRef idx="minor">
-            <a:schemeClr val="lt1"/>
-          </a:fontRef>
-        </p:style>
-        <p:txBody>
-          <a:bodyPr rtlCol="0" anchor="ctr" lIns="0" rIns="0" tIns="0" bIns="0"/>
-          <a:lstStyle/>
-          <a:p>
-            <a:pPr algn="ctr"/>
-            <a:r>
-              <a:rPr sz="1600" b="1">
-                <a:solidFill>
-                  <a:srgbClr val="22272E"/>
-                </a:solidFill>
-                <a:latin typeface="Calibri"/>
-              </a:rPr>
-              <a:t>5</a:t>
-            </a:r>
-          </a:p>
-        </p:txBody>
-      </p:sp>
-      <p:sp>
-        <p:nvSpPr>
-          <p:cNvPr id="21" name="TextBox 20"/>
-          <p:cNvSpPr txBox="1"/>
-          <p:nvPr/>
-        </p:nvSpPr>
-        <p:spPr>
-          <a:xfrm>
-            <a:off x="1554480" y="4617720"/>
-            <a:ext cx="4206240" cy="411480"/>
-          </a:xfrm>
-          <a:prstGeom prst="rect">
-            <a:avLst/>
-          </a:prstGeom>
-          <a:noFill/>
-        </p:spPr>
-        <p:txBody>
-          <a:bodyPr wrap="square" anchor="t" lIns="0" rIns="0" tIns="0" bIns="0">
-            <a:spAutoFit/>
-          </a:bodyPr>
-          <a:lstStyle/>
-          <a:p>
-            <a:pPr algn="l">
-              <a:spcAft>
-                <a:spcPts val="600"/>
-              </a:spcAft>
-            </a:pPr>
-            <a:r>
-              <a:rPr sz="1800" b="1" i="0">
-                <a:solidFill>
-                  <a:srgbClr val="22272E"/>
-                </a:solidFill>
-                <a:latin typeface="Calibri"/>
-              </a:rPr>
-              <a:t>Ngưỡng do M31 chọn</a:t>
-            </a:r>
-          </a:p>
-        </p:txBody>
-      </p:sp>
-      <p:sp>
-        <p:nvSpPr>
-          <p:cNvPr id="22" name="TextBox 21"/>
-          <p:cNvSpPr txBox="1"/>
-          <p:nvPr/>
-        </p:nvSpPr>
-        <p:spPr>
-          <a:xfrm>
-            <a:off x="1554480" y="5029200"/>
-            <a:ext cx="4206240" cy="640080"/>
-          </a:xfrm>
-          <a:prstGeom prst="rect">
-            <a:avLst/>
-          </a:prstGeom>
-          <a:noFill/>
-        </p:spPr>
-        <p:txBody>
-          <a:bodyPr wrap="square" anchor="t" lIns="0" rIns="0" tIns="0" bIns="0">
-            <a:spAutoFit/>
-          </a:bodyPr>
-          <a:lstStyle/>
-          <a:p>
-            <a:pPr algn="l">
-              <a:spcAft>
-                <a:spcPts val="600"/>
-              </a:spcAft>
-            </a:pPr>
-            <a:r>
-              <a:rPr sz="1400" b="0" i="0">
-                <a:solidFill>
-                  <a:srgbClr val="4A5560"/>
-                </a:solidFill>
-                <a:latin typeface="Calibri"/>
-              </a:rPr>
-              <a:t>Confidence thấp &lt; 0,5; box nhỏ &lt; 32×32 px</a:t>
-            </a:r>
-          </a:p>
-        </p:txBody>
-      </p:sp>
-      <p:sp>
-        <p:nvSpPr>
-          <p:cNvPr id="23" name="Rounded Rectangle 22"/>
-          <p:cNvSpPr/>
-          <p:nvPr/>
-        </p:nvSpPr>
-        <p:spPr>
-          <a:xfrm>
-            <a:off x="6172200" y="4434840"/>
-            <a:ext cx="5440680" cy="1280160"/>
-          </a:xfrm>
-          <a:prstGeom prst="roundRect">
-            <a:avLst>
-              <a:gd name="adj" fmla="val 8000"/>
-            </a:avLst>
-          </a:prstGeom>
-          <a:solidFill>
-            <a:srgbClr val="F1F3F5"/>
-          </a:solidFill>
-          <a:ln>
-            <a:noFill/>
-          </a:ln>
-          <a:effectLst/>
-        </p:spPr>
-        <p:style>
-          <a:lnRef idx="1">
-            <a:schemeClr val="accent1"/>
-          </a:lnRef>
-          <a:fillRef idx="3">
-            <a:schemeClr val="accent1"/>
-          </a:fillRef>
-          <a:effectRef idx="2">
-            <a:schemeClr val="accent1"/>
-          </a:effectRef>
-          <a:fontRef idx="minor">
-            <a:schemeClr val="lt1"/>
-          </a:fontRef>
-        </p:style>
-        <p:txBody>
-          <a:bodyPr rtlCol="0" anchor="ctr"/>
-          <a:lstStyle/>
-          <a:p>
-            <a:pPr algn="ctr"/>
-          </a:p>
-        </p:txBody>
-      </p:sp>
-      <p:sp>
-        <p:nvSpPr>
-          <p:cNvPr id="24" name="Oval 23"/>
-          <p:cNvSpPr/>
-          <p:nvPr/>
-        </p:nvSpPr>
-        <p:spPr>
-          <a:xfrm>
-            <a:off x="6446520" y="4818888"/>
-            <a:ext cx="502920" cy="502920"/>
-          </a:xfrm>
-          <a:prstGeom prst="ellipse">
-            <a:avLst/>
-          </a:prstGeom>
-          <a:solidFill>
-            <a:srgbClr val="F2B705"/>
-          </a:solidFill>
-          <a:ln>
-            <a:noFill/>
-          </a:ln>
-          <a:effectLst/>
-        </p:spPr>
-        <p:style>
-          <a:lnRef idx="1">
-            <a:schemeClr val="accent1"/>
-          </a:lnRef>
-          <a:fillRef idx="3">
-            <a:schemeClr val="accent1"/>
-          </a:fillRef>
-          <a:effectRef idx="2">
-            <a:schemeClr val="accent1"/>
-          </a:effectRef>
-          <a:fontRef idx="minor">
-            <a:schemeClr val="lt1"/>
-          </a:fontRef>
-        </p:style>
-        <p:txBody>
-          <a:bodyPr rtlCol="0" anchor="ctr" lIns="0" rIns="0" tIns="0" bIns="0"/>
-          <a:lstStyle/>
-          <a:p>
-            <a:pPr algn="ctr"/>
-            <a:r>
-              <a:rPr sz="1600" b="1">
-                <a:solidFill>
-                  <a:srgbClr val="22272E"/>
-                </a:solidFill>
-                <a:latin typeface="Calibri"/>
-              </a:rPr>
-              <a:t>6</a:t>
-            </a:r>
-          </a:p>
-        </p:txBody>
-      </p:sp>
-      <p:sp>
-        <p:nvSpPr>
-          <p:cNvPr id="25" name="TextBox 24"/>
-          <p:cNvSpPr txBox="1"/>
-          <p:nvPr/>
-        </p:nvSpPr>
-        <p:spPr>
-          <a:xfrm>
-            <a:off x="7178040" y="4617720"/>
-            <a:ext cx="4206240" cy="411480"/>
-          </a:xfrm>
-          <a:prstGeom prst="rect">
-            <a:avLst/>
-          </a:prstGeom>
-          <a:noFill/>
-        </p:spPr>
-        <p:txBody>
-          <a:bodyPr wrap="square" anchor="t" lIns="0" rIns="0" tIns="0" bIns="0">
-            <a:spAutoFit/>
-          </a:bodyPr>
-          <a:lstStyle/>
-          <a:p>
-            <a:pPr algn="l">
-              <a:spcAft>
-                <a:spcPts val="600"/>
-              </a:spcAft>
-            </a:pPr>
-            <a:r>
-              <a:rPr sz="1800" b="1" i="0">
-                <a:solidFill>
-                  <a:srgbClr val="22272E"/>
-                </a:solidFill>
-                <a:latin typeface="Calibri"/>
-              </a:rPr>
-              <a:t>Quyết định</a:t>
-            </a:r>
-          </a:p>
-        </p:txBody>
-      </p:sp>
-      <p:sp>
-        <p:nvSpPr>
-          <p:cNvPr id="26" name="TextBox 25"/>
-          <p:cNvSpPr txBox="1"/>
-          <p:nvPr/>
-        </p:nvSpPr>
-        <p:spPr>
-          <a:xfrm>
-            <a:off x="7178040" y="5029200"/>
-            <a:ext cx="4206240" cy="640080"/>
-          </a:xfrm>
-          <a:prstGeom prst="rect">
-            <a:avLst/>
-          </a:prstGeom>
-          <a:noFill/>
-        </p:spPr>
-        <p:txBody>
-          <a:bodyPr wrap="square" anchor="t" lIns="0" rIns="0" tIns="0" bIns="0">
-            <a:spAutoFit/>
-          </a:bodyPr>
-          <a:lstStyle/>
-          <a:p>
-            <a:pPr algn="l">
-              <a:spcAft>
-                <a:spcPts val="600"/>
-              </a:spcAft>
-            </a:pPr>
-            <a:r>
-              <a:rPr sz="1400" b="0" i="0">
-                <a:solidFill>
-                  <a:srgbClr val="4A5560"/>
-                </a:solidFill>
-                <a:latin typeface="Calibri"/>
-              </a:rPr>
-              <a:t>Không bật mô hình hiệu chỉnh; không tuyên bố độ chính xác</a:t>
+              <a:t>Không phải kết quả đại diện cho toàn bộ BDD100K; không có model nào được coi là tốt nhất.</a:t>
             </a:r>
           </a:p>
         </p:txBody>
@@ -9578,6 +9231,1133 @@
 </file>
 
 <file path=ppt/slides/slide8.xml><?xml version="1.0" encoding="utf-8"?>
+<p:sld xmlns:a="http://schemas.openxmlformats.org/drawingml/2006/main" xmlns:p="http://schemas.openxmlformats.org/presentationml/2006/main" xmlns:r="http://schemas.openxmlformats.org/officeDocument/2006/relationships">
+  <p:cSld>
+    <p:bg>
+      <p:bgPr>
+        <a:solidFill>
+          <a:srgbClr val="FFFFFF"/>
+        </a:solidFill>
+        <a:effectLst/>
+      </p:bgPr>
+    </p:bg>
+    <p:spTree>
+      <p:nvGrpSpPr>
+        <p:cNvPr id="1" name=""/>
+        <p:cNvGrpSpPr/>
+        <p:nvPr/>
+      </p:nvGrpSpPr>
+      <p:grpSpPr/>
+      <p:sp>
+        <p:nvSpPr>
+          <p:cNvPr id="2" name="Title"/>
+          <p:cNvSpPr txBox="1"/>
+          <p:nvPr/>
+        </p:nvSpPr>
+        <p:spPr>
+          <a:xfrm>
+            <a:off x="548640" y="411480"/>
+            <a:ext cx="11064240" cy="822960"/>
+          </a:xfrm>
+          <a:prstGeom prst="rect">
+            <a:avLst/>
+          </a:prstGeom>
+          <a:noFill/>
+        </p:spPr>
+        <p:txBody>
+          <a:bodyPr wrap="square" anchor="t" lIns="0" rIns="0" tIns="0" bIns="0">
+            <a:spAutoFit/>
+          </a:bodyPr>
+          <a:lstStyle/>
+          <a:p>
+            <a:pPr algn="l">
+              <a:spcAft>
+                <a:spcPts val="600"/>
+              </a:spcAft>
+            </a:pPr>
+            <a:r>
+              <a:rPr sz="3400" b="1" i="0">
+                <a:solidFill>
+                  <a:srgbClr val="22272E"/>
+                </a:solidFill>
+                <a:latin typeface="Cambria"/>
+              </a:rPr>
+              <a:t>Giới hạn cần nói rõ</a:t>
+            </a:r>
+          </a:p>
+        </p:txBody>
+      </p:sp>
+      <p:sp>
+        <p:nvSpPr>
+          <p:cNvPr id="3" name="Rounded Rectangle 2"/>
+          <p:cNvSpPr/>
+          <p:nvPr/>
+        </p:nvSpPr>
+        <p:spPr>
+          <a:xfrm>
+            <a:off x="548640" y="1508760"/>
+            <a:ext cx="5440680" cy="1280160"/>
+          </a:xfrm>
+          <a:prstGeom prst="roundRect">
+            <a:avLst>
+              <a:gd name="adj" fmla="val 8000"/>
+            </a:avLst>
+          </a:prstGeom>
+          <a:solidFill>
+            <a:srgbClr val="F1F3F5"/>
+          </a:solidFill>
+          <a:ln>
+            <a:noFill/>
+          </a:ln>
+          <a:effectLst/>
+        </p:spPr>
+        <p:style>
+          <a:lnRef idx="1">
+            <a:schemeClr val="accent1"/>
+          </a:lnRef>
+          <a:fillRef idx="3">
+            <a:schemeClr val="accent1"/>
+          </a:fillRef>
+          <a:effectRef idx="2">
+            <a:schemeClr val="accent1"/>
+          </a:effectRef>
+          <a:fontRef idx="minor">
+            <a:schemeClr val="lt1"/>
+          </a:fontRef>
+        </p:style>
+        <p:txBody>
+          <a:bodyPr rtlCol="0" anchor="ctr"/>
+          <a:lstStyle/>
+          <a:p>
+            <a:pPr algn="ctr"/>
+          </a:p>
+        </p:txBody>
+      </p:sp>
+      <p:sp>
+        <p:nvSpPr>
+          <p:cNvPr id="4" name="Oval 3"/>
+          <p:cNvSpPr/>
+          <p:nvPr/>
+        </p:nvSpPr>
+        <p:spPr>
+          <a:xfrm>
+            <a:off x="822960" y="1892808"/>
+            <a:ext cx="502920" cy="502920"/>
+          </a:xfrm>
+          <a:prstGeom prst="ellipse">
+            <a:avLst/>
+          </a:prstGeom>
+          <a:solidFill>
+            <a:srgbClr val="F2B705"/>
+          </a:solidFill>
+          <a:ln>
+            <a:noFill/>
+          </a:ln>
+          <a:effectLst/>
+        </p:spPr>
+        <p:style>
+          <a:lnRef idx="1">
+            <a:schemeClr val="accent1"/>
+          </a:lnRef>
+          <a:fillRef idx="3">
+            <a:schemeClr val="accent1"/>
+          </a:fillRef>
+          <a:effectRef idx="2">
+            <a:schemeClr val="accent1"/>
+          </a:effectRef>
+          <a:fontRef idx="minor">
+            <a:schemeClr val="lt1"/>
+          </a:fontRef>
+        </p:style>
+        <p:txBody>
+          <a:bodyPr rtlCol="0" anchor="ctr" lIns="0" rIns="0" tIns="0" bIns="0"/>
+          <a:lstStyle/>
+          <a:p>
+            <a:pPr algn="ctr"/>
+            <a:r>
+              <a:rPr sz="1600" b="1">
+                <a:solidFill>
+                  <a:srgbClr val="22272E"/>
+                </a:solidFill>
+                <a:latin typeface="Calibri"/>
+              </a:rPr>
+              <a:t>1</a:t>
+            </a:r>
+          </a:p>
+        </p:txBody>
+      </p:sp>
+      <p:sp>
+        <p:nvSpPr>
+          <p:cNvPr id="5" name="TextBox 4"/>
+          <p:cNvSpPr txBox="1"/>
+          <p:nvPr/>
+        </p:nvSpPr>
+        <p:spPr>
+          <a:xfrm>
+            <a:off x="1554480" y="1691640"/>
+            <a:ext cx="4206240" cy="411480"/>
+          </a:xfrm>
+          <a:prstGeom prst="rect">
+            <a:avLst/>
+          </a:prstGeom>
+          <a:noFill/>
+        </p:spPr>
+        <p:txBody>
+          <a:bodyPr wrap="square" anchor="t" lIns="0" rIns="0" tIns="0" bIns="0">
+            <a:spAutoFit/>
+          </a:bodyPr>
+          <a:lstStyle/>
+          <a:p>
+            <a:pPr algn="l">
+              <a:spcAft>
+                <a:spcPts val="600"/>
+              </a:spcAft>
+            </a:pPr>
+            <a:r>
+              <a:rPr sz="1800" b="1" i="0">
+                <a:solidFill>
+                  <a:srgbClr val="22272E"/>
+                </a:solidFill>
+                <a:latin typeface="Calibri"/>
+              </a:rPr>
+              <a:t>Mẫu nhỏ</a:t>
+            </a:r>
+          </a:p>
+        </p:txBody>
+      </p:sp>
+      <p:sp>
+        <p:nvSpPr>
+          <p:cNvPr id="6" name="TextBox 5"/>
+          <p:cNvSpPr txBox="1"/>
+          <p:nvPr/>
+        </p:nvSpPr>
+        <p:spPr>
+          <a:xfrm>
+            <a:off x="1554480" y="2103120"/>
+            <a:ext cx="4206240" cy="640080"/>
+          </a:xfrm>
+          <a:prstGeom prst="rect">
+            <a:avLst/>
+          </a:prstGeom>
+          <a:noFill/>
+        </p:spPr>
+        <p:txBody>
+          <a:bodyPr wrap="square" anchor="t" lIns="0" rIns="0" tIns="0" bIns="0">
+            <a:spAutoFit/>
+          </a:bodyPr>
+          <a:lstStyle/>
+          <a:p>
+            <a:pPr algn="l">
+              <a:spcAft>
+                <a:spcPts val="600"/>
+              </a:spcAft>
+            </a:pPr>
+            <a:r>
+              <a:rPr sz="1400" b="0" i="0">
+                <a:solidFill>
+                  <a:srgbClr val="4A5560"/>
+                </a:solidFill>
+                <a:latin typeface="Calibri"/>
+              </a:rPr>
+              <a:t>100 ảnh, 1 lớp, 13 ca sửa mỗi task — không đại diện BDD100K</a:t>
+            </a:r>
+          </a:p>
+        </p:txBody>
+      </p:sp>
+      <p:sp>
+        <p:nvSpPr>
+          <p:cNvPr id="7" name="Rounded Rectangle 6"/>
+          <p:cNvSpPr/>
+          <p:nvPr/>
+        </p:nvSpPr>
+        <p:spPr>
+          <a:xfrm>
+            <a:off x="6172200" y="1508760"/>
+            <a:ext cx="5440680" cy="1280160"/>
+          </a:xfrm>
+          <a:prstGeom prst="roundRect">
+            <a:avLst>
+              <a:gd name="adj" fmla="val 8000"/>
+            </a:avLst>
+          </a:prstGeom>
+          <a:solidFill>
+            <a:srgbClr val="F1F3F5"/>
+          </a:solidFill>
+          <a:ln>
+            <a:noFill/>
+          </a:ln>
+          <a:effectLst/>
+        </p:spPr>
+        <p:style>
+          <a:lnRef idx="1">
+            <a:schemeClr val="accent1"/>
+          </a:lnRef>
+          <a:fillRef idx="3">
+            <a:schemeClr val="accent1"/>
+          </a:fillRef>
+          <a:effectRef idx="2">
+            <a:schemeClr val="accent1"/>
+          </a:effectRef>
+          <a:fontRef idx="minor">
+            <a:schemeClr val="lt1"/>
+          </a:fontRef>
+        </p:style>
+        <p:txBody>
+          <a:bodyPr rtlCol="0" anchor="ctr"/>
+          <a:lstStyle/>
+          <a:p>
+            <a:pPr algn="ctr"/>
+          </a:p>
+        </p:txBody>
+      </p:sp>
+      <p:sp>
+        <p:nvSpPr>
+          <p:cNvPr id="8" name="Oval 7"/>
+          <p:cNvSpPr/>
+          <p:nvPr/>
+        </p:nvSpPr>
+        <p:spPr>
+          <a:xfrm>
+            <a:off x="6446520" y="1892808"/>
+            <a:ext cx="502920" cy="502920"/>
+          </a:xfrm>
+          <a:prstGeom prst="ellipse">
+            <a:avLst/>
+          </a:prstGeom>
+          <a:solidFill>
+            <a:srgbClr val="F2B705"/>
+          </a:solidFill>
+          <a:ln>
+            <a:noFill/>
+          </a:ln>
+          <a:effectLst/>
+        </p:spPr>
+        <p:style>
+          <a:lnRef idx="1">
+            <a:schemeClr val="accent1"/>
+          </a:lnRef>
+          <a:fillRef idx="3">
+            <a:schemeClr val="accent1"/>
+          </a:fillRef>
+          <a:effectRef idx="2">
+            <a:schemeClr val="accent1"/>
+          </a:effectRef>
+          <a:fontRef idx="minor">
+            <a:schemeClr val="lt1"/>
+          </a:fontRef>
+        </p:style>
+        <p:txBody>
+          <a:bodyPr rtlCol="0" anchor="ctr" lIns="0" rIns="0" tIns="0" bIns="0"/>
+          <a:lstStyle/>
+          <a:p>
+            <a:pPr algn="ctr"/>
+            <a:r>
+              <a:rPr sz="1600" b="1">
+                <a:solidFill>
+                  <a:srgbClr val="22272E"/>
+                </a:solidFill>
+                <a:latin typeface="Calibri"/>
+              </a:rPr>
+              <a:t>2</a:t>
+            </a:r>
+          </a:p>
+        </p:txBody>
+      </p:sp>
+      <p:sp>
+        <p:nvSpPr>
+          <p:cNvPr id="9" name="TextBox 8"/>
+          <p:cNvSpPr txBox="1"/>
+          <p:nvPr/>
+        </p:nvSpPr>
+        <p:spPr>
+          <a:xfrm>
+            <a:off x="7178040" y="1691640"/>
+            <a:ext cx="4206240" cy="411480"/>
+          </a:xfrm>
+          <a:prstGeom prst="rect">
+            <a:avLst/>
+          </a:prstGeom>
+          <a:noFill/>
+        </p:spPr>
+        <p:txBody>
+          <a:bodyPr wrap="square" anchor="t" lIns="0" rIns="0" tIns="0" bIns="0">
+            <a:spAutoFit/>
+          </a:bodyPr>
+          <a:lstStyle/>
+          <a:p>
+            <a:pPr algn="l">
+              <a:spcAft>
+                <a:spcPts val="600"/>
+              </a:spcAft>
+            </a:pPr>
+            <a:r>
+              <a:rPr sz="1800" b="1" i="0">
+                <a:solidFill>
+                  <a:srgbClr val="22272E"/>
+                </a:solidFill>
+                <a:latin typeface="Calibri"/>
+              </a:rPr>
+              <a:t>Baseline giả định</a:t>
+            </a:r>
+          </a:p>
+        </p:txBody>
+      </p:sp>
+      <p:sp>
+        <p:nvSpPr>
+          <p:cNvPr id="10" name="TextBox 9"/>
+          <p:cNvSpPr txBox="1"/>
+          <p:nvPr/>
+        </p:nvSpPr>
+        <p:spPr>
+          <a:xfrm>
+            <a:off x="7178040" y="2103120"/>
+            <a:ext cx="4206240" cy="640080"/>
+          </a:xfrm>
+          <a:prstGeom prst="rect">
+            <a:avLst/>
+          </a:prstGeom>
+          <a:noFill/>
+        </p:spPr>
+        <p:txBody>
+          <a:bodyPr wrap="square" anchor="t" lIns="0" rIns="0" tIns="0" bIns="0">
+            <a:spAutoFit/>
+          </a:bodyPr>
+          <a:lstStyle/>
+          <a:p>
+            <a:pPr algn="l">
+              <a:spcAft>
+                <a:spcPts val="600"/>
+              </a:spcAft>
+            </a:pPr>
+            <a:r>
+              <a:rPr sz="1400" b="0" i="0">
+                <a:solidFill>
+                  <a:srgbClr val="4A5560"/>
+                </a:solidFill>
+                <a:latin typeface="Calibri"/>
+              </a:rPr>
+              <a:t>Hằng số thời gian sửa đặt tay; điểm chất lượng chưa kiểm chứng</a:t>
+            </a:r>
+          </a:p>
+        </p:txBody>
+      </p:sp>
+      <p:sp>
+        <p:nvSpPr>
+          <p:cNvPr id="11" name="Rounded Rectangle 10"/>
+          <p:cNvSpPr/>
+          <p:nvPr/>
+        </p:nvSpPr>
+        <p:spPr>
+          <a:xfrm>
+            <a:off x="548640" y="2971800"/>
+            <a:ext cx="5440680" cy="1280160"/>
+          </a:xfrm>
+          <a:prstGeom prst="roundRect">
+            <a:avLst>
+              <a:gd name="adj" fmla="val 8000"/>
+            </a:avLst>
+          </a:prstGeom>
+          <a:solidFill>
+            <a:srgbClr val="F1F3F5"/>
+          </a:solidFill>
+          <a:ln>
+            <a:noFill/>
+          </a:ln>
+          <a:effectLst/>
+        </p:spPr>
+        <p:style>
+          <a:lnRef idx="1">
+            <a:schemeClr val="accent1"/>
+          </a:lnRef>
+          <a:fillRef idx="3">
+            <a:schemeClr val="accent1"/>
+          </a:fillRef>
+          <a:effectRef idx="2">
+            <a:schemeClr val="accent1"/>
+          </a:effectRef>
+          <a:fontRef idx="minor">
+            <a:schemeClr val="lt1"/>
+          </a:fontRef>
+        </p:style>
+        <p:txBody>
+          <a:bodyPr rtlCol="0" anchor="ctr"/>
+          <a:lstStyle/>
+          <a:p>
+            <a:pPr algn="ctr"/>
+          </a:p>
+        </p:txBody>
+      </p:sp>
+      <p:sp>
+        <p:nvSpPr>
+          <p:cNvPr id="12" name="Oval 11"/>
+          <p:cNvSpPr/>
+          <p:nvPr/>
+        </p:nvSpPr>
+        <p:spPr>
+          <a:xfrm>
+            <a:off x="822960" y="3355848"/>
+            <a:ext cx="502920" cy="502920"/>
+          </a:xfrm>
+          <a:prstGeom prst="ellipse">
+            <a:avLst/>
+          </a:prstGeom>
+          <a:solidFill>
+            <a:srgbClr val="F2B705"/>
+          </a:solidFill>
+          <a:ln>
+            <a:noFill/>
+          </a:ln>
+          <a:effectLst/>
+        </p:spPr>
+        <p:style>
+          <a:lnRef idx="1">
+            <a:schemeClr val="accent1"/>
+          </a:lnRef>
+          <a:fillRef idx="3">
+            <a:schemeClr val="accent1"/>
+          </a:fillRef>
+          <a:effectRef idx="2">
+            <a:schemeClr val="accent1"/>
+          </a:effectRef>
+          <a:fontRef idx="minor">
+            <a:schemeClr val="lt1"/>
+          </a:fontRef>
+        </p:style>
+        <p:txBody>
+          <a:bodyPr rtlCol="0" anchor="ctr" lIns="0" rIns="0" tIns="0" bIns="0"/>
+          <a:lstStyle/>
+          <a:p>
+            <a:pPr algn="ctr"/>
+            <a:r>
+              <a:rPr sz="1600" b="1">
+                <a:solidFill>
+                  <a:srgbClr val="22272E"/>
+                </a:solidFill>
+                <a:latin typeface="Calibri"/>
+              </a:rPr>
+              <a:t>3</a:t>
+            </a:r>
+          </a:p>
+        </p:txBody>
+      </p:sp>
+      <p:sp>
+        <p:nvSpPr>
+          <p:cNvPr id="13" name="TextBox 12"/>
+          <p:cNvSpPr txBox="1"/>
+          <p:nvPr/>
+        </p:nvSpPr>
+        <p:spPr>
+          <a:xfrm>
+            <a:off x="1554480" y="3154680"/>
+            <a:ext cx="4206240" cy="411480"/>
+          </a:xfrm>
+          <a:prstGeom prst="rect">
+            <a:avLst/>
+          </a:prstGeom>
+          <a:noFill/>
+        </p:spPr>
+        <p:txBody>
+          <a:bodyPr wrap="square" anchor="t" lIns="0" rIns="0" tIns="0" bIns="0">
+            <a:spAutoFit/>
+          </a:bodyPr>
+          <a:lstStyle/>
+          <a:p>
+            <a:pPr algn="l">
+              <a:spcAft>
+                <a:spcPts val="600"/>
+              </a:spcAft>
+            </a:pPr>
+            <a:r>
+              <a:rPr sz="1800" b="1" i="0">
+                <a:solidFill>
+                  <a:srgbClr val="22272E"/>
+                </a:solidFill>
+                <a:latin typeface="Calibri"/>
+              </a:rPr>
+              <a:t>SAM</a:t>
+            </a:r>
+          </a:p>
+        </p:txBody>
+      </p:sp>
+      <p:sp>
+        <p:nvSpPr>
+          <p:cNvPr id="14" name="TextBox 13"/>
+          <p:cNvSpPr txBox="1"/>
+          <p:nvPr/>
+        </p:nvSpPr>
+        <p:spPr>
+          <a:xfrm>
+            <a:off x="1554480" y="3566160"/>
+            <a:ext cx="4206240" cy="640080"/>
+          </a:xfrm>
+          <a:prstGeom prst="rect">
+            <a:avLst/>
+          </a:prstGeom>
+          <a:noFill/>
+        </p:spPr>
+        <p:txBody>
+          <a:bodyPr wrap="square" anchor="t" lIns="0" rIns="0" tIns="0" bIns="0">
+            <a:spAutoFit/>
+          </a:bodyPr>
+          <a:lstStyle/>
+          <a:p>
+            <a:pPr algn="l">
+              <a:spcAft>
+                <a:spcPts val="600"/>
+              </a:spcAft>
+            </a:pPr>
+            <a:r>
+              <a:rPr sz="1400" b="0" i="0">
+                <a:solidFill>
+                  <a:srgbClr val="4A5560"/>
+                </a:solidFill>
+                <a:latin typeface="Calibri"/>
+              </a:rPr>
+              <a:t>Không có confidence riêng; dùng confidence box YOLO</a:t>
+            </a:r>
+          </a:p>
+        </p:txBody>
+      </p:sp>
+      <p:sp>
+        <p:nvSpPr>
+          <p:cNvPr id="15" name="Rounded Rectangle 14"/>
+          <p:cNvSpPr/>
+          <p:nvPr/>
+        </p:nvSpPr>
+        <p:spPr>
+          <a:xfrm>
+            <a:off x="6172200" y="2971800"/>
+            <a:ext cx="5440680" cy="1280160"/>
+          </a:xfrm>
+          <a:prstGeom prst="roundRect">
+            <a:avLst>
+              <a:gd name="adj" fmla="val 8000"/>
+            </a:avLst>
+          </a:prstGeom>
+          <a:solidFill>
+            <a:srgbClr val="F1F3F5"/>
+          </a:solidFill>
+          <a:ln>
+            <a:noFill/>
+          </a:ln>
+          <a:effectLst/>
+        </p:spPr>
+        <p:style>
+          <a:lnRef idx="1">
+            <a:schemeClr val="accent1"/>
+          </a:lnRef>
+          <a:fillRef idx="3">
+            <a:schemeClr val="accent1"/>
+          </a:fillRef>
+          <a:effectRef idx="2">
+            <a:schemeClr val="accent1"/>
+          </a:effectRef>
+          <a:fontRef idx="minor">
+            <a:schemeClr val="lt1"/>
+          </a:fontRef>
+        </p:style>
+        <p:txBody>
+          <a:bodyPr rtlCol="0" anchor="ctr"/>
+          <a:lstStyle/>
+          <a:p>
+            <a:pPr algn="ctr"/>
+          </a:p>
+        </p:txBody>
+      </p:sp>
+      <p:sp>
+        <p:nvSpPr>
+          <p:cNvPr id="16" name="Oval 15"/>
+          <p:cNvSpPr/>
+          <p:nvPr/>
+        </p:nvSpPr>
+        <p:spPr>
+          <a:xfrm>
+            <a:off x="6446520" y="3355848"/>
+            <a:ext cx="502920" cy="502920"/>
+          </a:xfrm>
+          <a:prstGeom prst="ellipse">
+            <a:avLst/>
+          </a:prstGeom>
+          <a:solidFill>
+            <a:srgbClr val="F2B705"/>
+          </a:solidFill>
+          <a:ln>
+            <a:noFill/>
+          </a:ln>
+          <a:effectLst/>
+        </p:spPr>
+        <p:style>
+          <a:lnRef idx="1">
+            <a:schemeClr val="accent1"/>
+          </a:lnRef>
+          <a:fillRef idx="3">
+            <a:schemeClr val="accent1"/>
+          </a:fillRef>
+          <a:effectRef idx="2">
+            <a:schemeClr val="accent1"/>
+          </a:effectRef>
+          <a:fontRef idx="minor">
+            <a:schemeClr val="lt1"/>
+          </a:fontRef>
+        </p:style>
+        <p:txBody>
+          <a:bodyPr rtlCol="0" anchor="ctr" lIns="0" rIns="0" tIns="0" bIns="0"/>
+          <a:lstStyle/>
+          <a:p>
+            <a:pPr algn="ctr"/>
+            <a:r>
+              <a:rPr sz="1600" b="1">
+                <a:solidFill>
+                  <a:srgbClr val="22272E"/>
+                </a:solidFill>
+                <a:latin typeface="Calibri"/>
+              </a:rPr>
+              <a:t>4</a:t>
+            </a:r>
+          </a:p>
+        </p:txBody>
+      </p:sp>
+      <p:sp>
+        <p:nvSpPr>
+          <p:cNvPr id="17" name="TextBox 16"/>
+          <p:cNvSpPr txBox="1"/>
+          <p:nvPr/>
+        </p:nvSpPr>
+        <p:spPr>
+          <a:xfrm>
+            <a:off x="7178040" y="3154680"/>
+            <a:ext cx="4206240" cy="411480"/>
+          </a:xfrm>
+          <a:prstGeom prst="rect">
+            <a:avLst/>
+          </a:prstGeom>
+          <a:noFill/>
+        </p:spPr>
+        <p:txBody>
+          <a:bodyPr wrap="square" anchor="t" lIns="0" rIns="0" tIns="0" bIns="0">
+            <a:spAutoFit/>
+          </a:bodyPr>
+          <a:lstStyle/>
+          <a:p>
+            <a:pPr algn="l">
+              <a:spcAft>
+                <a:spcPts val="600"/>
+              </a:spcAft>
+            </a:pPr>
+            <a:r>
+              <a:rPr sz="1800" b="1" i="0">
+                <a:solidFill>
+                  <a:srgbClr val="22272E"/>
+                </a:solidFill>
+                <a:latin typeface="Calibri"/>
+              </a:rPr>
+              <a:t>Đo lường</a:t>
+            </a:r>
+          </a:p>
+        </p:txBody>
+      </p:sp>
+      <p:sp>
+        <p:nvSpPr>
+          <p:cNvPr id="18" name="TextBox 17"/>
+          <p:cNvSpPr txBox="1"/>
+          <p:nvPr/>
+        </p:nvSpPr>
+        <p:spPr>
+          <a:xfrm>
+            <a:off x="7178040" y="3566160"/>
+            <a:ext cx="4206240" cy="640080"/>
+          </a:xfrm>
+          <a:prstGeom prst="rect">
+            <a:avLst/>
+          </a:prstGeom>
+          <a:noFill/>
+        </p:spPr>
+        <p:txBody>
+          <a:bodyPr wrap="square" anchor="t" lIns="0" rIns="0" tIns="0" bIns="0">
+            <a:spAutoFit/>
+          </a:bodyPr>
+          <a:lstStyle/>
+          <a:p>
+            <a:pPr algn="l">
+              <a:spcAft>
+                <a:spcPts val="600"/>
+              </a:spcAft>
+            </a:pPr>
+            <a:r>
+              <a:rPr sz="1400" b="0" i="0">
+                <a:solidFill>
+                  <a:srgbClr val="4A5560"/>
+                </a:solidFill>
+                <a:latin typeface="Calibri"/>
+              </a:rPr>
+              <a:t>Thời gian sửa do nhóm ghi; không có đánh giá với ground truth</a:t>
+            </a:r>
+          </a:p>
+        </p:txBody>
+      </p:sp>
+      <p:sp>
+        <p:nvSpPr>
+          <p:cNvPr id="19" name="Rounded Rectangle 18"/>
+          <p:cNvSpPr/>
+          <p:nvPr/>
+        </p:nvSpPr>
+        <p:spPr>
+          <a:xfrm>
+            <a:off x="548640" y="4434840"/>
+            <a:ext cx="5440680" cy="1280160"/>
+          </a:xfrm>
+          <a:prstGeom prst="roundRect">
+            <a:avLst>
+              <a:gd name="adj" fmla="val 8000"/>
+            </a:avLst>
+          </a:prstGeom>
+          <a:solidFill>
+            <a:srgbClr val="F1F3F5"/>
+          </a:solidFill>
+          <a:ln>
+            <a:noFill/>
+          </a:ln>
+          <a:effectLst/>
+        </p:spPr>
+        <p:style>
+          <a:lnRef idx="1">
+            <a:schemeClr val="accent1"/>
+          </a:lnRef>
+          <a:fillRef idx="3">
+            <a:schemeClr val="accent1"/>
+          </a:fillRef>
+          <a:effectRef idx="2">
+            <a:schemeClr val="accent1"/>
+          </a:effectRef>
+          <a:fontRef idx="minor">
+            <a:schemeClr val="lt1"/>
+          </a:fontRef>
+        </p:style>
+        <p:txBody>
+          <a:bodyPr rtlCol="0" anchor="ctr"/>
+          <a:lstStyle/>
+          <a:p>
+            <a:pPr algn="ctr"/>
+          </a:p>
+        </p:txBody>
+      </p:sp>
+      <p:sp>
+        <p:nvSpPr>
+          <p:cNvPr id="20" name="Oval 19"/>
+          <p:cNvSpPr/>
+          <p:nvPr/>
+        </p:nvSpPr>
+        <p:spPr>
+          <a:xfrm>
+            <a:off x="822960" y="4818888"/>
+            <a:ext cx="502920" cy="502920"/>
+          </a:xfrm>
+          <a:prstGeom prst="ellipse">
+            <a:avLst/>
+          </a:prstGeom>
+          <a:solidFill>
+            <a:srgbClr val="F2B705"/>
+          </a:solidFill>
+          <a:ln>
+            <a:noFill/>
+          </a:ln>
+          <a:effectLst/>
+        </p:spPr>
+        <p:style>
+          <a:lnRef idx="1">
+            <a:schemeClr val="accent1"/>
+          </a:lnRef>
+          <a:fillRef idx="3">
+            <a:schemeClr val="accent1"/>
+          </a:fillRef>
+          <a:effectRef idx="2">
+            <a:schemeClr val="accent1"/>
+          </a:effectRef>
+          <a:fontRef idx="minor">
+            <a:schemeClr val="lt1"/>
+          </a:fontRef>
+        </p:style>
+        <p:txBody>
+          <a:bodyPr rtlCol="0" anchor="ctr" lIns="0" rIns="0" tIns="0" bIns="0"/>
+          <a:lstStyle/>
+          <a:p>
+            <a:pPr algn="ctr"/>
+            <a:r>
+              <a:rPr sz="1600" b="1">
+                <a:solidFill>
+                  <a:srgbClr val="22272E"/>
+                </a:solidFill>
+                <a:latin typeface="Calibri"/>
+              </a:rPr>
+              <a:t>5</a:t>
+            </a:r>
+          </a:p>
+        </p:txBody>
+      </p:sp>
+      <p:sp>
+        <p:nvSpPr>
+          <p:cNvPr id="21" name="TextBox 20"/>
+          <p:cNvSpPr txBox="1"/>
+          <p:nvPr/>
+        </p:nvSpPr>
+        <p:spPr>
+          <a:xfrm>
+            <a:off x="1554480" y="4617720"/>
+            <a:ext cx="4206240" cy="411480"/>
+          </a:xfrm>
+          <a:prstGeom prst="rect">
+            <a:avLst/>
+          </a:prstGeom>
+          <a:noFill/>
+        </p:spPr>
+        <p:txBody>
+          <a:bodyPr wrap="square" anchor="t" lIns="0" rIns="0" tIns="0" bIns="0">
+            <a:spAutoFit/>
+          </a:bodyPr>
+          <a:lstStyle/>
+          <a:p>
+            <a:pPr algn="l">
+              <a:spcAft>
+                <a:spcPts val="600"/>
+              </a:spcAft>
+            </a:pPr>
+            <a:r>
+              <a:rPr sz="1800" b="1" i="0">
+                <a:solidFill>
+                  <a:srgbClr val="22272E"/>
+                </a:solidFill>
+                <a:latin typeface="Calibri"/>
+              </a:rPr>
+              <a:t>Ngưỡng do M31 chọn</a:t>
+            </a:r>
+          </a:p>
+        </p:txBody>
+      </p:sp>
+      <p:sp>
+        <p:nvSpPr>
+          <p:cNvPr id="22" name="TextBox 21"/>
+          <p:cNvSpPr txBox="1"/>
+          <p:nvPr/>
+        </p:nvSpPr>
+        <p:spPr>
+          <a:xfrm>
+            <a:off x="1554480" y="5029200"/>
+            <a:ext cx="4206240" cy="640080"/>
+          </a:xfrm>
+          <a:prstGeom prst="rect">
+            <a:avLst/>
+          </a:prstGeom>
+          <a:noFill/>
+        </p:spPr>
+        <p:txBody>
+          <a:bodyPr wrap="square" anchor="t" lIns="0" rIns="0" tIns="0" bIns="0">
+            <a:spAutoFit/>
+          </a:bodyPr>
+          <a:lstStyle/>
+          <a:p>
+            <a:pPr algn="l">
+              <a:spcAft>
+                <a:spcPts val="600"/>
+              </a:spcAft>
+            </a:pPr>
+            <a:r>
+              <a:rPr sz="1400" b="0" i="0">
+                <a:solidFill>
+                  <a:srgbClr val="4A5560"/>
+                </a:solidFill>
+                <a:latin typeface="Calibri"/>
+              </a:rPr>
+              <a:t>Confidence thấp &lt; 0,5; box nhỏ &lt; 32×32 px</a:t>
+            </a:r>
+          </a:p>
+        </p:txBody>
+      </p:sp>
+      <p:sp>
+        <p:nvSpPr>
+          <p:cNvPr id="23" name="Rounded Rectangle 22"/>
+          <p:cNvSpPr/>
+          <p:nvPr/>
+        </p:nvSpPr>
+        <p:spPr>
+          <a:xfrm>
+            <a:off x="6172200" y="4434840"/>
+            <a:ext cx="5440680" cy="1280160"/>
+          </a:xfrm>
+          <a:prstGeom prst="roundRect">
+            <a:avLst>
+              <a:gd name="adj" fmla="val 8000"/>
+            </a:avLst>
+          </a:prstGeom>
+          <a:solidFill>
+            <a:srgbClr val="F1F3F5"/>
+          </a:solidFill>
+          <a:ln>
+            <a:noFill/>
+          </a:ln>
+          <a:effectLst/>
+        </p:spPr>
+        <p:style>
+          <a:lnRef idx="1">
+            <a:schemeClr val="accent1"/>
+          </a:lnRef>
+          <a:fillRef idx="3">
+            <a:schemeClr val="accent1"/>
+          </a:fillRef>
+          <a:effectRef idx="2">
+            <a:schemeClr val="accent1"/>
+          </a:effectRef>
+          <a:fontRef idx="minor">
+            <a:schemeClr val="lt1"/>
+          </a:fontRef>
+        </p:style>
+        <p:txBody>
+          <a:bodyPr rtlCol="0" anchor="ctr"/>
+          <a:lstStyle/>
+          <a:p>
+            <a:pPr algn="ctr"/>
+          </a:p>
+        </p:txBody>
+      </p:sp>
+      <p:sp>
+        <p:nvSpPr>
+          <p:cNvPr id="24" name="Oval 23"/>
+          <p:cNvSpPr/>
+          <p:nvPr/>
+        </p:nvSpPr>
+        <p:spPr>
+          <a:xfrm>
+            <a:off x="6446520" y="4818888"/>
+            <a:ext cx="502920" cy="502920"/>
+          </a:xfrm>
+          <a:prstGeom prst="ellipse">
+            <a:avLst/>
+          </a:prstGeom>
+          <a:solidFill>
+            <a:srgbClr val="F2B705"/>
+          </a:solidFill>
+          <a:ln>
+            <a:noFill/>
+          </a:ln>
+          <a:effectLst/>
+        </p:spPr>
+        <p:style>
+          <a:lnRef idx="1">
+            <a:schemeClr val="accent1"/>
+          </a:lnRef>
+          <a:fillRef idx="3">
+            <a:schemeClr val="accent1"/>
+          </a:fillRef>
+          <a:effectRef idx="2">
+            <a:schemeClr val="accent1"/>
+          </a:effectRef>
+          <a:fontRef idx="minor">
+            <a:schemeClr val="lt1"/>
+          </a:fontRef>
+        </p:style>
+        <p:txBody>
+          <a:bodyPr rtlCol="0" anchor="ctr" lIns="0" rIns="0" tIns="0" bIns="0"/>
+          <a:lstStyle/>
+          <a:p>
+            <a:pPr algn="ctr"/>
+            <a:r>
+              <a:rPr sz="1600" b="1">
+                <a:solidFill>
+                  <a:srgbClr val="22272E"/>
+                </a:solidFill>
+                <a:latin typeface="Calibri"/>
+              </a:rPr>
+              <a:t>6</a:t>
+            </a:r>
+          </a:p>
+        </p:txBody>
+      </p:sp>
+      <p:sp>
+        <p:nvSpPr>
+          <p:cNvPr id="25" name="TextBox 24"/>
+          <p:cNvSpPr txBox="1"/>
+          <p:nvPr/>
+        </p:nvSpPr>
+        <p:spPr>
+          <a:xfrm>
+            <a:off x="7178040" y="4617720"/>
+            <a:ext cx="4206240" cy="411480"/>
+          </a:xfrm>
+          <a:prstGeom prst="rect">
+            <a:avLst/>
+          </a:prstGeom>
+          <a:noFill/>
+        </p:spPr>
+        <p:txBody>
+          <a:bodyPr wrap="square" anchor="t" lIns="0" rIns="0" tIns="0" bIns="0">
+            <a:spAutoFit/>
+          </a:bodyPr>
+          <a:lstStyle/>
+          <a:p>
+            <a:pPr algn="l">
+              <a:spcAft>
+                <a:spcPts val="600"/>
+              </a:spcAft>
+            </a:pPr>
+            <a:r>
+              <a:rPr sz="1800" b="1" i="0">
+                <a:solidFill>
+                  <a:srgbClr val="22272E"/>
+                </a:solidFill>
+                <a:latin typeface="Calibri"/>
+              </a:rPr>
+              <a:t>Quyết định</a:t>
+            </a:r>
+          </a:p>
+        </p:txBody>
+      </p:sp>
+      <p:sp>
+        <p:nvSpPr>
+          <p:cNvPr id="26" name="TextBox 25"/>
+          <p:cNvSpPr txBox="1"/>
+          <p:nvPr/>
+        </p:nvSpPr>
+        <p:spPr>
+          <a:xfrm>
+            <a:off x="7178040" y="5029200"/>
+            <a:ext cx="4206240" cy="640080"/>
+          </a:xfrm>
+          <a:prstGeom prst="rect">
+            <a:avLst/>
+          </a:prstGeom>
+          <a:noFill/>
+        </p:spPr>
+        <p:txBody>
+          <a:bodyPr wrap="square" anchor="t" lIns="0" rIns="0" tIns="0" bIns="0">
+            <a:spAutoFit/>
+          </a:bodyPr>
+          <a:lstStyle/>
+          <a:p>
+            <a:pPr algn="l">
+              <a:spcAft>
+                <a:spcPts val="600"/>
+              </a:spcAft>
+            </a:pPr>
+            <a:r>
+              <a:rPr sz="1400" b="0" i="0">
+                <a:solidFill>
+                  <a:srgbClr val="4A5560"/>
+                </a:solidFill>
+                <a:latin typeface="Calibri"/>
+              </a:rPr>
+              <a:t>Không bật mô hình hiệu chỉnh; không tuyên bố độ chính xác</a:t>
+            </a:r>
+          </a:p>
+        </p:txBody>
+      </p:sp>
+    </p:spTree>
+  </p:cSld>
+  <p:clrMapOvr>
+    <a:masterClrMapping/>
+  </p:clrMapOvr>
+</p:sld>
+</file>
+
+<file path=ppt/slides/slide9.xml><?xml version="1.0" encoding="utf-8"?>
 <p:sld xmlns:a="http://schemas.openxmlformats.org/drawingml/2006/main" xmlns:p="http://schemas.openxmlformats.org/presentationml/2006/main" xmlns:r="http://schemas.openxmlformats.org/officeDocument/2006/relationships">
   <p:cSld>
     <p:bg>

</xml_diff>